<commit_message>
Presentation: two admin dashboard slides (live overview, per-student concept map)
</commit_message>
<xml_diff>
--- a/presentation/Masar-presentation.pptx
+++ b/presentation/Masar-presentation.pptx
@@ -13,9 +13,11 @@
     <p:sldId id="261" r:id="rId7"/>
     <p:sldId id="262" r:id="rId8"/>
     <p:sldId id="263" r:id="rId9"/>
+    <p:sldId id="264" r:id="rId10"/>
+    <p:sldId id="265" r:id="rId11"/>
   </p:sldIdLst>
   <p:notesMasterIdLst>
-    <p:notesMasterId r:id="rId10"/>
+    <p:notesMasterId r:id="rId12"/>
   </p:notesMasterIdLst>
   <p:sldSz cx="9144000" cy="5143500"/>
   <p:notesSz cx="5143500" cy="9144000"/>
@@ -551,6 +553,95 @@
 </p:notes>
 </file>
 
+<file path=ppt/notesSlides/notesSlide10.xml><?xml version="1.0" encoding="utf-8"?>
+<p:notes xmlns:a="http://schemas.openxmlformats.org/drawingml/2006/main" xmlns:r="http://schemas.openxmlformats.org/officeDocument/2006/relationships" xmlns:p="http://schemas.openxmlformats.org/presentationml/2006/main">
+  <p:cSld>
+    <p:spTree>
+      <p:nvGrpSpPr>
+        <p:cNvPr id="1" name=""/>
+        <p:cNvGrpSpPr/>
+        <p:nvPr/>
+      </p:nvGrpSpPr>
+      <p:grpSpPr>
+        <a:xfrm>
+          <a:off x="0" y="0"/>
+          <a:ext cx="0" cy="0"/>
+          <a:chOff x="0" y="0"/>
+          <a:chExt cx="0" cy="0"/>
+        </a:xfrm>
+      </p:grpSpPr>
+      <p:sp>
+        <p:nvSpPr>
+          <p:cNvPr id="2" name="Slide Image Placeholder 1"/>
+          <p:cNvSpPr>
+            <a:spLocks noGrp="1" noRot="1" noChangeAspect="1"/>
+          </p:cNvSpPr>
+          <p:nvPr>
+            <p:ph type="sldImg"/>
+          </p:nvPr>
+        </p:nvSpPr>
+        <p:spPr/>
+      </p:sp>
+      <p:sp>
+        <p:nvSpPr>
+          <p:cNvPr id="3" name="Notes Placeholder 2"/>
+          <p:cNvSpPr>
+            <a:spLocks noGrp="1"/>
+          </p:cNvSpPr>
+          <p:nvPr>
+            <p:ph type="body" idx="1"/>
+          </p:nvPr>
+        </p:nvSpPr>
+        <p:spPr/>
+        <p:txBody>
+          <a:bodyPr/>
+          <a:lstStyle/>
+          <a:p>
+            <a:r>
+              <a:rPr lang="en-US" dirty="0"/>
+              <a:t>تحدّي المسابقة كان: الطلاب بيتعلّموا بسرعات مختلفة ودعم غير متساوٍ.
+مع «مسار»، الدعم صار متساوي، مجاني، ومصمّم لكل طالب. شكراً لكم.</a:t>
+            </a:r>
+            <a:endParaRPr lang="en-US" dirty="0"/>
+          </a:p>
+        </p:txBody>
+      </p:sp>
+      <p:sp>
+        <p:nvSpPr>
+          <p:cNvPr id="4" name="Slide Number Placeholder 3"/>
+          <p:cNvSpPr>
+            <a:spLocks noGrp="1"/>
+          </p:cNvSpPr>
+          <p:nvPr>
+            <p:ph type="sldNum" sz="quarter" idx="10"/>
+          </p:nvPr>
+        </p:nvSpPr>
+        <p:spPr/>
+        <p:txBody>
+          <a:bodyPr/>
+          <a:lstStyle/>
+          <a:p>
+            <a:fld id="{F7021451-1387-4CA6-816F-3879F97B5CBC}" type="slidenum">
+              <a:rPr lang="en-US"/>
+              <a:t>10</a:t>
+            </a:fld>
+            <a:endParaRPr lang="en-US"/>
+          </a:p>
+        </p:txBody>
+      </p:sp>
+    </p:spTree>
+    <p:extLst>
+      <p:ext uri="{BB962C8B-B14F-4D97-AF65-F5344CB8AC3E}">
+        <p14:creationId xmlns:p14="http://schemas.microsoft.com/office/powerpoint/2010/main" val="1024086991"/>
+      </p:ext>
+    </p:extLst>
+  </p:cSld>
+  <p:clrMapOvr>
+    <a:masterClrMapping/>
+  </p:clrMapOvr>
+</p:notes>
+</file>
+
 <file path=ppt/notesSlides/notesSlide2.xml><?xml version="1.0" encoding="utf-8"?>
 <p:notes xmlns:a="http://schemas.openxmlformats.org/drawingml/2006/main" xmlns:r="http://schemas.openxmlformats.org/officeDocument/2006/relationships" xmlns:p="http://schemas.openxmlformats.org/presentationml/2006/main">
   <p:cSld>
@@ -1046,9 +1137,8 @@
           <a:p>
             <a:r>
               <a:rPr lang="en-US" dirty="0"/>
-              <a:t>لكن الأهم من كل هذا... لو عملنا أفضل ذكاء اصطناعي في العالم وكان مكلف، ما حلّينا مشكلة الطالب اللي ما معه مصاري.
-عشان هيك، رفيق مبني على نموذج لغة محلي (Local LLM). تكلفة تشغيله وشرحه للطالب؟ صفر تقريباً.
-هذا بيعني إن مسار بيقدر يوصل لكل طالب في كل محافظة في الأردن، ويضل مجاني ومستدام.</a:t>
+              <a:t>وعشان نتابع كل هاد، عملنا لوحة إدارة بتتحدّث لحظياً مع التطبيق.
+كل طالب بيسجّل بيظهر هون فوراً برقمه من 5 خانات. منشوف نشاط اليوم ودقّة الإجابات ومتوسط الجاهزية، وكم رسالة جاوبها رفيق من الجهاز المحلي.</a:t>
             </a:r>
             <a:endParaRPr lang="en-US" dirty="0"/>
           </a:p>
@@ -1136,8 +1226,8 @@
           <a:p>
             <a:r>
               <a:rPr lang="en-US" dirty="0"/>
-              <a:t>تحدّي المسابقة كان: الطلاب بيتعلّموا بسرعات مختلفة ودعم غير متساوٍ.
-مع «مسار»، الدعم صار متساوي، مجاني، ومصمّم لكل طالب. شكراً لكم.</a:t>
+              <a:t>ومنقدر نفتح أي طالب ونشوف مواده وجاهزيته بكل مادة، وخريطة المفاهيم تبعته مفهوم بمفهوم: نفس الخريطة اللي بيشوفها على تلفونه.
+وأي سؤال جوابه بالمصدر مشكوك فيه بينعلّم وما بينعرض للطلاب.</a:t>
             </a:r>
             <a:endParaRPr lang="en-US" dirty="0"/>
           </a:p>
@@ -1161,6 +1251,96 @@
             <a:fld id="{F7021451-1387-4CA6-816F-3879F97B5CBC}" type="slidenum">
               <a:rPr lang="en-US"/>
               <a:t>8</a:t>
+            </a:fld>
+            <a:endParaRPr lang="en-US"/>
+          </a:p>
+        </p:txBody>
+      </p:sp>
+    </p:spTree>
+    <p:extLst>
+      <p:ext uri="{BB962C8B-B14F-4D97-AF65-F5344CB8AC3E}">
+        <p14:creationId xmlns:p14="http://schemas.microsoft.com/office/powerpoint/2010/main" val="1024086991"/>
+      </p:ext>
+    </p:extLst>
+  </p:cSld>
+  <p:clrMapOvr>
+    <a:masterClrMapping/>
+  </p:clrMapOvr>
+</p:notes>
+</file>
+
+<file path=ppt/notesSlides/notesSlide9.xml><?xml version="1.0" encoding="utf-8"?>
+<p:notes xmlns:a="http://schemas.openxmlformats.org/drawingml/2006/main" xmlns:r="http://schemas.openxmlformats.org/officeDocument/2006/relationships" xmlns:p="http://schemas.openxmlformats.org/presentationml/2006/main">
+  <p:cSld>
+    <p:spTree>
+      <p:nvGrpSpPr>
+        <p:cNvPr id="1" name=""/>
+        <p:cNvGrpSpPr/>
+        <p:nvPr/>
+      </p:nvGrpSpPr>
+      <p:grpSpPr>
+        <a:xfrm>
+          <a:off x="0" y="0"/>
+          <a:ext cx="0" cy="0"/>
+          <a:chOff x="0" y="0"/>
+          <a:chExt cx="0" cy="0"/>
+        </a:xfrm>
+      </p:grpSpPr>
+      <p:sp>
+        <p:nvSpPr>
+          <p:cNvPr id="2" name="Slide Image Placeholder 1"/>
+          <p:cNvSpPr>
+            <a:spLocks noGrp="1" noRot="1" noChangeAspect="1"/>
+          </p:cNvSpPr>
+          <p:nvPr>
+            <p:ph type="sldImg"/>
+          </p:nvPr>
+        </p:nvSpPr>
+        <p:spPr/>
+      </p:sp>
+      <p:sp>
+        <p:nvSpPr>
+          <p:cNvPr id="3" name="Notes Placeholder 2"/>
+          <p:cNvSpPr>
+            <a:spLocks noGrp="1"/>
+          </p:cNvSpPr>
+          <p:nvPr>
+            <p:ph type="body" idx="1"/>
+          </p:nvPr>
+        </p:nvSpPr>
+        <p:spPr/>
+        <p:txBody>
+          <a:bodyPr/>
+          <a:lstStyle/>
+          <a:p>
+            <a:r>
+              <a:rPr lang="en-US" dirty="0"/>
+              <a:t>لكن الأهم من كل هذا... لو عملنا أفضل ذكاء اصطناعي في العالم وكان مكلف، ما حلّينا مشكلة الطالب اللي ما معه مصاري.
+عشان هيك، رفيق مبني على نموذج لغة محلي (Local LLM). تكلفة تشغيله وشرحه للطالب؟ صفر تقريباً.
+هذا بيعني إن مسار بيقدر يوصل لكل طالب في كل محافظة في الأردن، ويضل مجاني ومستدام.</a:t>
+            </a:r>
+            <a:endParaRPr lang="en-US" dirty="0"/>
+          </a:p>
+        </p:txBody>
+      </p:sp>
+      <p:sp>
+        <p:nvSpPr>
+          <p:cNvPr id="4" name="Slide Number Placeholder 3"/>
+          <p:cNvSpPr>
+            <a:spLocks noGrp="1"/>
+          </p:cNvSpPr>
+          <p:nvPr>
+            <p:ph type="sldNum" sz="quarter" idx="10"/>
+          </p:nvPr>
+        </p:nvSpPr>
+        <p:spPr/>
+        <p:txBody>
+          <a:bodyPr/>
+          <a:lstStyle/>
+          <a:p>
+            <a:fld id="{F7021451-1387-4CA6-816F-3879F97B5CBC}" type="slidenum">
+              <a:rPr lang="en-US"/>
+              <a:t>9</a:t>
             </a:fld>
             <a:endParaRPr lang="en-US"/>
           </a:p>
@@ -1542,6 +1722,62 @@
 </p:sld>
 </file>
 
+<file path=ppt/slides/slide10.xml><?xml version="1.0" encoding="utf-8"?>
+<p:sld xmlns:a="http://schemas.openxmlformats.org/drawingml/2006/main" xmlns:r="http://schemas.openxmlformats.org/officeDocument/2006/relationships" xmlns:p="http://schemas.openxmlformats.org/presentationml/2006/main">
+  <p:cSld name="Slide 10">
+    <p:bg>
+      <p:bgPr>
+        <a:solidFill>
+          <a:srgbClr val="F5F7FA"/>
+        </a:solidFill>
+      </p:bgPr>
+    </p:bg>
+    <p:spTree>
+      <p:nvGrpSpPr>
+        <p:cNvPr id="1" name=""/>
+        <p:cNvGrpSpPr/>
+        <p:nvPr/>
+      </p:nvGrpSpPr>
+      <p:grpSpPr>
+        <a:xfrm>
+          <a:off x="0" y="0"/>
+          <a:ext cx="0" cy="0"/>
+          <a:chOff x="0" y="0"/>
+          <a:chExt cx="0" cy="0"/>
+        </a:xfrm>
+      </p:grpSpPr>
+      <p:pic>
+        <p:nvPicPr>
+          <p:cNvPr id="2" name="Slide 10: شكراً لكم" descr="شكراً لكم">    </p:cNvPr>
+          <p:cNvPicPr>
+            <a:picLocks noChangeAspect="1"/>
+          </p:cNvPicPr>
+          <p:nvPr/>
+        </p:nvPicPr>
+        <p:blipFill>
+          <a:blip r:embed="rId1"/>
+          <a:stretch>
+            <a:fillRect/>
+          </a:stretch>
+        </p:blipFill>
+        <p:spPr>
+          <a:xfrm>
+            <a:off x="0" y="0"/>
+            <a:ext cx="9144000" cy="5143500"/>
+          </a:xfrm>
+          <a:prstGeom prst="rect">
+            <a:avLst/>
+          </a:prstGeom>
+        </p:spPr>
+      </p:pic>
+    </p:spTree>
+  </p:cSld>
+  <p:clrMapOvr>
+    <a:masterClrMapping/>
+  </p:clrMapOvr>
+</p:sld>
+</file>
+
 <file path=ppt/slides/slide2.xml><?xml version="1.0" encoding="utf-8"?>
 <p:sld xmlns:a="http://schemas.openxmlformats.org/drawingml/2006/main" xmlns:r="http://schemas.openxmlformats.org/officeDocument/2006/relationships" xmlns:p="http://schemas.openxmlformats.org/presentationml/2006/main">
   <p:cSld name="Slide 2">
@@ -1848,7 +2084,7 @@
       </p:grpSpPr>
       <p:pic>
         <p:nvPicPr>
-          <p:cNvPr id="2" name="Slide 7: التكلفة: نموذج محلي" descr="التكلفة: نموذج محلي">    </p:cNvPr>
+          <p:cNvPr id="2" name="Slide 7: لوحة الإدارة: نظرة عامة" descr="لوحة الإدارة: نظرة عامة">    </p:cNvPr>
           <p:cNvPicPr>
             <a:picLocks noChangeAspect="1"/>
           </p:cNvPicPr>
@@ -1904,7 +2140,63 @@
       </p:grpSpPr>
       <p:pic>
         <p:nvPicPr>
-          <p:cNvPr id="2" name="Slide 8: شكراً لكم" descr="شكراً لكم">    </p:cNvPr>
+          <p:cNvPr id="2" name="Slide 8: لوحة الإدارة: الطلاب" descr="لوحة الإدارة: الطلاب">    </p:cNvPr>
+          <p:cNvPicPr>
+            <a:picLocks noChangeAspect="1"/>
+          </p:cNvPicPr>
+          <p:nvPr/>
+        </p:nvPicPr>
+        <p:blipFill>
+          <a:blip r:embed="rId1"/>
+          <a:stretch>
+            <a:fillRect/>
+          </a:stretch>
+        </p:blipFill>
+        <p:spPr>
+          <a:xfrm>
+            <a:off x="0" y="0"/>
+            <a:ext cx="9144000" cy="5143500"/>
+          </a:xfrm>
+          <a:prstGeom prst="rect">
+            <a:avLst/>
+          </a:prstGeom>
+        </p:spPr>
+      </p:pic>
+    </p:spTree>
+  </p:cSld>
+  <p:clrMapOvr>
+    <a:masterClrMapping/>
+  </p:clrMapOvr>
+</p:sld>
+</file>
+
+<file path=ppt/slides/slide9.xml><?xml version="1.0" encoding="utf-8"?>
+<p:sld xmlns:a="http://schemas.openxmlformats.org/drawingml/2006/main" xmlns:r="http://schemas.openxmlformats.org/officeDocument/2006/relationships" xmlns:p="http://schemas.openxmlformats.org/presentationml/2006/main">
+  <p:cSld name="Slide 9">
+    <p:bg>
+      <p:bgPr>
+        <a:solidFill>
+          <a:srgbClr val="F5F7FA"/>
+        </a:solidFill>
+      </p:bgPr>
+    </p:bg>
+    <p:spTree>
+      <p:nvGrpSpPr>
+        <p:cNvPr id="1" name=""/>
+        <p:cNvGrpSpPr/>
+        <p:nvPr/>
+      </p:nvGrpSpPr>
+      <p:grpSpPr>
+        <a:xfrm>
+          <a:off x="0" y="0"/>
+          <a:ext cx="0" cy="0"/>
+          <a:chOff x="0" y="0"/>
+          <a:chExt cx="0" cy="0"/>
+        </a:xfrm>
+      </p:grpSpPr>
+      <p:pic>
+        <p:nvPicPr>
+          <p:cNvPr id="2" name="Slide 9: التكلفة: نموذج محلي" descr="التكلفة: نموذج محلي">    </p:cNvPr>
           <p:cNvPicPr>
             <a:picLocks noChangeAspect="1"/>
           </p:cNvPicPr>

</xml_diff>

<commit_message>
Presentation: admin dashboard as its own deck; app deck back to 8 slides
</commit_message>
<xml_diff>
--- a/presentation/Masar-presentation.pptx
+++ b/presentation/Masar-presentation.pptx
@@ -13,11 +13,9 @@
     <p:sldId id="261" r:id="rId7"/>
     <p:sldId id="262" r:id="rId8"/>
     <p:sldId id="263" r:id="rId9"/>
-    <p:sldId id="264" r:id="rId10"/>
-    <p:sldId id="265" r:id="rId11"/>
   </p:sldIdLst>
   <p:notesMasterIdLst>
-    <p:notesMasterId r:id="rId12"/>
+    <p:notesMasterId r:id="rId10"/>
   </p:notesMasterIdLst>
   <p:sldSz cx="9144000" cy="5143500"/>
   <p:notesSz cx="5143500" cy="9144000"/>
@@ -553,95 +551,6 @@
 </p:notes>
 </file>
 
-<file path=ppt/notesSlides/notesSlide10.xml><?xml version="1.0" encoding="utf-8"?>
-<p:notes xmlns:a="http://schemas.openxmlformats.org/drawingml/2006/main" xmlns:r="http://schemas.openxmlformats.org/officeDocument/2006/relationships" xmlns:p="http://schemas.openxmlformats.org/presentationml/2006/main">
-  <p:cSld>
-    <p:spTree>
-      <p:nvGrpSpPr>
-        <p:cNvPr id="1" name=""/>
-        <p:cNvGrpSpPr/>
-        <p:nvPr/>
-      </p:nvGrpSpPr>
-      <p:grpSpPr>
-        <a:xfrm>
-          <a:off x="0" y="0"/>
-          <a:ext cx="0" cy="0"/>
-          <a:chOff x="0" y="0"/>
-          <a:chExt cx="0" cy="0"/>
-        </a:xfrm>
-      </p:grpSpPr>
-      <p:sp>
-        <p:nvSpPr>
-          <p:cNvPr id="2" name="Slide Image Placeholder 1"/>
-          <p:cNvSpPr>
-            <a:spLocks noGrp="1" noRot="1" noChangeAspect="1"/>
-          </p:cNvSpPr>
-          <p:nvPr>
-            <p:ph type="sldImg"/>
-          </p:nvPr>
-        </p:nvSpPr>
-        <p:spPr/>
-      </p:sp>
-      <p:sp>
-        <p:nvSpPr>
-          <p:cNvPr id="3" name="Notes Placeholder 2"/>
-          <p:cNvSpPr>
-            <a:spLocks noGrp="1"/>
-          </p:cNvSpPr>
-          <p:nvPr>
-            <p:ph type="body" idx="1"/>
-          </p:nvPr>
-        </p:nvSpPr>
-        <p:spPr/>
-        <p:txBody>
-          <a:bodyPr/>
-          <a:lstStyle/>
-          <a:p>
-            <a:r>
-              <a:rPr lang="en-US" dirty="0"/>
-              <a:t>تحدّي المسابقة كان: الطلاب بيتعلّموا بسرعات مختلفة ودعم غير متساوٍ.
-مع «مسار»، الدعم صار متساوي، مجاني، ومصمّم لكل طالب. شكراً لكم.</a:t>
-            </a:r>
-            <a:endParaRPr lang="en-US" dirty="0"/>
-          </a:p>
-        </p:txBody>
-      </p:sp>
-      <p:sp>
-        <p:nvSpPr>
-          <p:cNvPr id="4" name="Slide Number Placeholder 3"/>
-          <p:cNvSpPr>
-            <a:spLocks noGrp="1"/>
-          </p:cNvSpPr>
-          <p:nvPr>
-            <p:ph type="sldNum" sz="quarter" idx="10"/>
-          </p:nvPr>
-        </p:nvSpPr>
-        <p:spPr/>
-        <p:txBody>
-          <a:bodyPr/>
-          <a:lstStyle/>
-          <a:p>
-            <a:fld id="{F7021451-1387-4CA6-816F-3879F97B5CBC}" type="slidenum">
-              <a:rPr lang="en-US"/>
-              <a:t>10</a:t>
-            </a:fld>
-            <a:endParaRPr lang="en-US"/>
-          </a:p>
-        </p:txBody>
-      </p:sp>
-    </p:spTree>
-    <p:extLst>
-      <p:ext uri="{BB962C8B-B14F-4D97-AF65-F5344CB8AC3E}">
-        <p14:creationId xmlns:p14="http://schemas.microsoft.com/office/powerpoint/2010/main" val="1024086991"/>
-      </p:ext>
-    </p:extLst>
-  </p:cSld>
-  <p:clrMapOvr>
-    <a:masterClrMapping/>
-  </p:clrMapOvr>
-</p:notes>
-</file>
-
 <file path=ppt/notesSlides/notesSlide2.xml><?xml version="1.0" encoding="utf-8"?>
 <p:notes xmlns:a="http://schemas.openxmlformats.org/drawingml/2006/main" xmlns:r="http://schemas.openxmlformats.org/officeDocument/2006/relationships" xmlns:p="http://schemas.openxmlformats.org/presentationml/2006/main">
   <p:cSld>
@@ -1137,8 +1046,9 @@
           <a:p>
             <a:r>
               <a:rPr lang="en-US" dirty="0"/>
-              <a:t>وعشان نتابع كل هاد، عملنا لوحة إدارة بتتحدّث لحظياً مع التطبيق.
-كل طالب بيسجّل بيظهر هون فوراً برقمه من 5 خانات. منشوف نشاط اليوم ودقّة الإجابات ومتوسط الجاهزية، وكم رسالة جاوبها رفيق من الجهاز المحلي.</a:t>
+              <a:t>لكن الأهم من كل هذا... لو عملنا أفضل ذكاء اصطناعي في العالم وكان مكلف، ما حلّينا مشكلة الطالب اللي ما معه مصاري.
+عشان هيك، رفيق مبني على نموذج لغة محلي (Local LLM). تكلفة تشغيله وشرحه للطالب؟ صفر تقريباً.
+هذا بيعني إن مسار بيقدر يوصل لكل طالب في كل محافظة في الأردن، ويضل مجاني ومستدام.</a:t>
             </a:r>
             <a:endParaRPr lang="en-US" dirty="0"/>
           </a:p>
@@ -1226,8 +1136,8 @@
           <a:p>
             <a:r>
               <a:rPr lang="en-US" dirty="0"/>
-              <a:t>ومنقدر نفتح أي طالب ونشوف مواده وجاهزيته بكل مادة، وخريطة المفاهيم تبعته مفهوم بمفهوم: نفس الخريطة اللي بيشوفها على تلفونه.
-وأي سؤال جوابه بالمصدر مشكوك فيه بينعلّم وما بينعرض للطلاب.</a:t>
+              <a:t>تحدّي المسابقة كان: الطلاب بيتعلّموا بسرعات مختلفة ودعم غير متساوٍ.
+مع «مسار»، الدعم صار متساوي، مجاني، ومصمّم لكل طالب. شكراً لكم.</a:t>
             </a:r>
             <a:endParaRPr lang="en-US" dirty="0"/>
           </a:p>
@@ -1251,96 +1161,6 @@
             <a:fld id="{F7021451-1387-4CA6-816F-3879F97B5CBC}" type="slidenum">
               <a:rPr lang="en-US"/>
               <a:t>8</a:t>
-            </a:fld>
-            <a:endParaRPr lang="en-US"/>
-          </a:p>
-        </p:txBody>
-      </p:sp>
-    </p:spTree>
-    <p:extLst>
-      <p:ext uri="{BB962C8B-B14F-4D97-AF65-F5344CB8AC3E}">
-        <p14:creationId xmlns:p14="http://schemas.microsoft.com/office/powerpoint/2010/main" val="1024086991"/>
-      </p:ext>
-    </p:extLst>
-  </p:cSld>
-  <p:clrMapOvr>
-    <a:masterClrMapping/>
-  </p:clrMapOvr>
-</p:notes>
-</file>
-
-<file path=ppt/notesSlides/notesSlide9.xml><?xml version="1.0" encoding="utf-8"?>
-<p:notes xmlns:a="http://schemas.openxmlformats.org/drawingml/2006/main" xmlns:r="http://schemas.openxmlformats.org/officeDocument/2006/relationships" xmlns:p="http://schemas.openxmlformats.org/presentationml/2006/main">
-  <p:cSld>
-    <p:spTree>
-      <p:nvGrpSpPr>
-        <p:cNvPr id="1" name=""/>
-        <p:cNvGrpSpPr/>
-        <p:nvPr/>
-      </p:nvGrpSpPr>
-      <p:grpSpPr>
-        <a:xfrm>
-          <a:off x="0" y="0"/>
-          <a:ext cx="0" cy="0"/>
-          <a:chOff x="0" y="0"/>
-          <a:chExt cx="0" cy="0"/>
-        </a:xfrm>
-      </p:grpSpPr>
-      <p:sp>
-        <p:nvSpPr>
-          <p:cNvPr id="2" name="Slide Image Placeholder 1"/>
-          <p:cNvSpPr>
-            <a:spLocks noGrp="1" noRot="1" noChangeAspect="1"/>
-          </p:cNvSpPr>
-          <p:nvPr>
-            <p:ph type="sldImg"/>
-          </p:nvPr>
-        </p:nvSpPr>
-        <p:spPr/>
-      </p:sp>
-      <p:sp>
-        <p:nvSpPr>
-          <p:cNvPr id="3" name="Notes Placeholder 2"/>
-          <p:cNvSpPr>
-            <a:spLocks noGrp="1"/>
-          </p:cNvSpPr>
-          <p:nvPr>
-            <p:ph type="body" idx="1"/>
-          </p:nvPr>
-        </p:nvSpPr>
-        <p:spPr/>
-        <p:txBody>
-          <a:bodyPr/>
-          <a:lstStyle/>
-          <a:p>
-            <a:r>
-              <a:rPr lang="en-US" dirty="0"/>
-              <a:t>لكن الأهم من كل هذا... لو عملنا أفضل ذكاء اصطناعي في العالم وكان مكلف، ما حلّينا مشكلة الطالب اللي ما معه مصاري.
-عشان هيك، رفيق مبني على نموذج لغة محلي (Local LLM). تكلفة تشغيله وشرحه للطالب؟ صفر تقريباً.
-هذا بيعني إن مسار بيقدر يوصل لكل طالب في كل محافظة في الأردن، ويضل مجاني ومستدام.</a:t>
-            </a:r>
-            <a:endParaRPr lang="en-US" dirty="0"/>
-          </a:p>
-        </p:txBody>
-      </p:sp>
-      <p:sp>
-        <p:nvSpPr>
-          <p:cNvPr id="4" name="Slide Number Placeholder 3"/>
-          <p:cNvSpPr>
-            <a:spLocks noGrp="1"/>
-          </p:cNvSpPr>
-          <p:nvPr>
-            <p:ph type="sldNum" sz="quarter" idx="10"/>
-          </p:nvPr>
-        </p:nvSpPr>
-        <p:spPr/>
-        <p:txBody>
-          <a:bodyPr/>
-          <a:lstStyle/>
-          <a:p>
-            <a:fld id="{F7021451-1387-4CA6-816F-3879F97B5CBC}" type="slidenum">
-              <a:rPr lang="en-US"/>
-              <a:t>9</a:t>
             </a:fld>
             <a:endParaRPr lang="en-US"/>
           </a:p>
@@ -1722,62 +1542,6 @@
 </p:sld>
 </file>
 
-<file path=ppt/slides/slide10.xml><?xml version="1.0" encoding="utf-8"?>
-<p:sld xmlns:a="http://schemas.openxmlformats.org/drawingml/2006/main" xmlns:r="http://schemas.openxmlformats.org/officeDocument/2006/relationships" xmlns:p="http://schemas.openxmlformats.org/presentationml/2006/main">
-  <p:cSld name="Slide 10">
-    <p:bg>
-      <p:bgPr>
-        <a:solidFill>
-          <a:srgbClr val="F5F7FA"/>
-        </a:solidFill>
-      </p:bgPr>
-    </p:bg>
-    <p:spTree>
-      <p:nvGrpSpPr>
-        <p:cNvPr id="1" name=""/>
-        <p:cNvGrpSpPr/>
-        <p:nvPr/>
-      </p:nvGrpSpPr>
-      <p:grpSpPr>
-        <a:xfrm>
-          <a:off x="0" y="0"/>
-          <a:ext cx="0" cy="0"/>
-          <a:chOff x="0" y="0"/>
-          <a:chExt cx="0" cy="0"/>
-        </a:xfrm>
-      </p:grpSpPr>
-      <p:pic>
-        <p:nvPicPr>
-          <p:cNvPr id="2" name="Slide 10: شكراً لكم" descr="شكراً لكم">    </p:cNvPr>
-          <p:cNvPicPr>
-            <a:picLocks noChangeAspect="1"/>
-          </p:cNvPicPr>
-          <p:nvPr/>
-        </p:nvPicPr>
-        <p:blipFill>
-          <a:blip r:embed="rId1"/>
-          <a:stretch>
-            <a:fillRect/>
-          </a:stretch>
-        </p:blipFill>
-        <p:spPr>
-          <a:xfrm>
-            <a:off x="0" y="0"/>
-            <a:ext cx="9144000" cy="5143500"/>
-          </a:xfrm>
-          <a:prstGeom prst="rect">
-            <a:avLst/>
-          </a:prstGeom>
-        </p:spPr>
-      </p:pic>
-    </p:spTree>
-  </p:cSld>
-  <p:clrMapOvr>
-    <a:masterClrMapping/>
-  </p:clrMapOvr>
-</p:sld>
-</file>
-
 <file path=ppt/slides/slide2.xml><?xml version="1.0" encoding="utf-8"?>
 <p:sld xmlns:a="http://schemas.openxmlformats.org/drawingml/2006/main" xmlns:r="http://schemas.openxmlformats.org/officeDocument/2006/relationships" xmlns:p="http://schemas.openxmlformats.org/presentationml/2006/main">
   <p:cSld name="Slide 2">
@@ -2084,7 +1848,7 @@
       </p:grpSpPr>
       <p:pic>
         <p:nvPicPr>
-          <p:cNvPr id="2" name="Slide 7: لوحة الإدارة: نظرة عامة" descr="لوحة الإدارة: نظرة عامة">    </p:cNvPr>
+          <p:cNvPr id="2" name="Slide 7: التكلفة: نموذج محلي" descr="التكلفة: نموذج محلي">    </p:cNvPr>
           <p:cNvPicPr>
             <a:picLocks noChangeAspect="1"/>
           </p:cNvPicPr>
@@ -2140,63 +1904,7 @@
       </p:grpSpPr>
       <p:pic>
         <p:nvPicPr>
-          <p:cNvPr id="2" name="Slide 8: لوحة الإدارة: الطلاب" descr="لوحة الإدارة: الطلاب">    </p:cNvPr>
-          <p:cNvPicPr>
-            <a:picLocks noChangeAspect="1"/>
-          </p:cNvPicPr>
-          <p:nvPr/>
-        </p:nvPicPr>
-        <p:blipFill>
-          <a:blip r:embed="rId1"/>
-          <a:stretch>
-            <a:fillRect/>
-          </a:stretch>
-        </p:blipFill>
-        <p:spPr>
-          <a:xfrm>
-            <a:off x="0" y="0"/>
-            <a:ext cx="9144000" cy="5143500"/>
-          </a:xfrm>
-          <a:prstGeom prst="rect">
-            <a:avLst/>
-          </a:prstGeom>
-        </p:spPr>
-      </p:pic>
-    </p:spTree>
-  </p:cSld>
-  <p:clrMapOvr>
-    <a:masterClrMapping/>
-  </p:clrMapOvr>
-</p:sld>
-</file>
-
-<file path=ppt/slides/slide9.xml><?xml version="1.0" encoding="utf-8"?>
-<p:sld xmlns:a="http://schemas.openxmlformats.org/drawingml/2006/main" xmlns:r="http://schemas.openxmlformats.org/officeDocument/2006/relationships" xmlns:p="http://schemas.openxmlformats.org/presentationml/2006/main">
-  <p:cSld name="Slide 9">
-    <p:bg>
-      <p:bgPr>
-        <a:solidFill>
-          <a:srgbClr val="F5F7FA"/>
-        </a:solidFill>
-      </p:bgPr>
-    </p:bg>
-    <p:spTree>
-      <p:nvGrpSpPr>
-        <p:cNvPr id="1" name=""/>
-        <p:cNvGrpSpPr/>
-        <p:nvPr/>
-      </p:nvGrpSpPr>
-      <p:grpSpPr>
-        <a:xfrm>
-          <a:off x="0" y="0"/>
-          <a:ext cx="0" cy="0"/>
-          <a:chOff x="0" y="0"/>
-          <a:chExt cx="0" cy="0"/>
-        </a:xfrm>
-      </p:grpSpPr>
-      <p:pic>
-        <p:nvPicPr>
-          <p:cNvPr id="2" name="Slide 9: التكلفة: نموذج محلي" descr="التكلفة: نموذج محلي">    </p:cNvPr>
+          <p:cNvPr id="2" name="Slide 8: شكراً لكم" descr="شكراً لكم">    </p:cNvPr>
           <p:cNvPicPr>
             <a:picLocks noChangeAspect="1"/>
           </p:cNvPicPr>

</xml_diff>